<commit_message>
Refactor backend into flat modules; refresh dataset, docs and Claude tooling
- Flatten backend/app into one module per concern (loaders, ingest, search,
  answer, guardrails, feedback, metrics, evals, api, db, llm, rules, schemas)
- Dataset quality pass: 24 meetings + 16 OOXML docs, re-dated to 2026
  (user-approved); golden eval set updated to match
- Docs: TECH.md, CODE_REVIEW.md, rewritten MEASUREMENT.md, stale paths and
  dates fixed in TASKS.md / backend README, refreshed project-status memory
- Claude Code: ruff PostToolUse hook and /verify project skill

Co-Authored-By: Claude Opus 5.5 <noreply@anthropic.com>
</commit_message>
<xml_diff>
--- a/data/documents/pptx/novadrive_audit_readout.pptx
+++ b/data/documents/pptx/novadrive_audit_readout.pptx
@@ -508,7 +508,7 @@
           <a:lstStyle/>
           <a:p>
             <a:r>
-              <a:t>Yesterday's customer audit was a complete triumph. NovaDrive officially certified our quality systems and signed off on production release.</a:t>
+              <a:t>Yesterday's customer audit was a complete triumph. NovaDrive officially certified our quality systems and approved the production ramp on an interim PSW.</a:t>
             </a:r>
           </a:p>
         </p:txBody>
@@ -3885,7 +3885,7 @@
           <a:lstStyle/>
           <a:p>
             <a:r>
-              <a:t>NovaDrive Customer Audit Readout — May 2024</a:t>
+              <a:t>NovaDrive Customer Audit Readout — May 2026</a:t>
             </a:r>
           </a:p>
         </p:txBody>
@@ -3936,7 +3936,7 @@
             </a:r>
             <a:r>
               <a:rPr sz="1800" b="0" i="0"/>
-              <a:t> May 13, 2024</a:t>
+              <a:t> May 11, 2026</a:t>
             </a:r>
           </a:p>
         </p:txBody>
@@ -4024,7 +4024,7 @@
             </a:r>
             <a:r>
               <a:rPr sz="2000" b="0" i="0"/>
-              <a:t> May 12, 2024 | Location: FastChip HQ (Austin, TX) &amp; Penang Fab (Remote)</a:t>
+              <a:t> May 10, 2026 | Location: FastChip HQ (Austin, TX) &amp; Penang Fab (Remote)</a:t>
             </a:r>
           </a:p>
           <a:p>
@@ -4070,7 +4070,7 @@
             <a:pPr lvl="1"/>
             <a:r>
               <a:rPr sz="1800" b="1" i="0"/>
-              <a:t>Production Part Approval Process (PPAP Level 3): FORMALLY APPROVED.</a:t>
+              <a:t>Production Part Approval Process (PPAP Level 3): INTERIM APPROVAL (full approval after the 1000-hour HTOL on June 2).</a:t>
             </a:r>
           </a:p>
         </p:txBody>
@@ -4311,7 +4311,7 @@
             <a:pPr lvl="1"/>
             <a:r>
               <a:rPr sz="1800" b="0" i="1"/>
-              <a:t>3. Problem Solving &amp; 8D Execution (CAR-2024-ND01):</a:t>
+              <a:t>3. Problem Solving &amp; 8D Execution (CAR-2026-ND01):</a:t>
             </a:r>
             <a:r>
               <a:rPr sz="1800" b="0" i="0"/>
@@ -4326,11 +4326,11 @@
             <a:pPr lvl="1"/>
             <a:r>
               <a:rPr sz="1800" b="0" i="1"/>
-              <a:t>4. Reliability Qualification (AEC-Q100 Data):</a:t>
+              <a:t>4. Reliability Qualification (AEC-Q100 Data): PASS on interim data (1000-hour HTOL completes June 2)</a:t>
             </a:r>
             <a:r>
               <a:rPr sz="1800" b="0" i="0"/>
-              <a:t> PASS (100%)</a:t>
+              <a:t/>
             </a:r>
           </a:p>
           <a:p>
@@ -4465,7 +4465,7 @@
             </a:r>
             <a:r>
               <a:rPr sz="1800" b="0" i="0"/>
-              <a:t> Kevin Tran presented 1000-hour HTOL, TC, and HAST datasets with zero failures across 231 units.</a:t>
+              <a:t> Kevin Tran presented Rev B early-life burn-in (0/800), HAST (0/231), the 168-hour HTOL pull (0/231) and live chamber logs; the 1000-hour readout is due June 2.</a:t>
             </a:r>
           </a:p>
           <a:p>
@@ -4680,22 +4680,22 @@
             <a:pPr lvl="1"/>
             <a:r>
               <a:rPr sz="1800" b="0" i="0"/>
-              <a:t>NovaDrive signed the formal </a:t>
+              <a:t>NovaDrive signed an interim Part Submission Warrant (PSW) for Volta-7 Rev B silicon; the full PSW follows the 1000-hour HTOL readout on June 2.</a:t>
             </a:r>
             <a:r>
               <a:rPr sz="1800" b="1" i="0"/>
-              <a:t>Part Submission Warrant (PSW)</a:t>
+              <a:t/>
             </a:r>
             <a:r>
               <a:rPr sz="1800" b="0" i="0"/>
-              <a:t> for Volta-7 Rev B silicon.</a:t>
+              <a:t/>
             </a:r>
           </a:p>
           <a:p>
             <a:pPr lvl="1"/>
             <a:r>
               <a:rPr sz="1800" b="0" i="0"/>
-              <a:t>Production purchase orders released for initial volume: 150,000 units in June 2024, ramping to 250,000 units/month by Q4 2024.</a:t>
+              <a:t>Production purchase orders released for initial volume: 150,000 units in June 2026, ramping to 250,000 units/month by Q4 2026.</a:t>
             </a:r>
           </a:p>
           <a:p>

</xml_diff>